<commit_message>
Passenger count now shows correctly (2/40 becomes 4/40 after tickets issued) Both Driver Dashboard and User TrackBus page show real-time updates Fresh data fetches on initial selection and on every socket event
</commit_message>
<xml_diff>
--- a/OnTime_Presentation_v2.pptx
+++ b/OnTime_Presentation_v2.pptx
@@ -314,7 +314,7 @@
           <a:p>
             <a:fld id="{5BCAD085-E8A6-8845-BD4E-CB4CCA059FC4}" type="datetimeFigureOut">
               <a:rPr lang="en-US" smtClean="0"/>
-              <a:t>2/19/2026</a:t>
+              <a:t>4/8/2026</a:t>
             </a:fld>
             <a:endParaRPr lang="en-US"/>
           </a:p>
@@ -482,7 +482,7 @@
           <a:p>
             <a:fld id="{5BCAD085-E8A6-8845-BD4E-CB4CCA059FC4}" type="datetimeFigureOut">
               <a:rPr lang="en-US" smtClean="0"/>
-              <a:t>2/19/2026</a:t>
+              <a:t>4/8/2026</a:t>
             </a:fld>
             <a:endParaRPr lang="en-US"/>
           </a:p>
@@ -660,7 +660,7 @@
           <a:p>
             <a:fld id="{5BCAD085-E8A6-8845-BD4E-CB4CCA059FC4}" type="datetimeFigureOut">
               <a:rPr lang="en-US" smtClean="0"/>
-              <a:t>2/19/2026</a:t>
+              <a:t>4/8/2026</a:t>
             </a:fld>
             <a:endParaRPr lang="en-US"/>
           </a:p>
@@ -828,7 +828,7 @@
           <a:p>
             <a:fld id="{5BCAD085-E8A6-8845-BD4E-CB4CCA059FC4}" type="datetimeFigureOut">
               <a:rPr lang="en-US" smtClean="0"/>
-              <a:t>2/19/2026</a:t>
+              <a:t>4/8/2026</a:t>
             </a:fld>
             <a:endParaRPr lang="en-US"/>
           </a:p>
@@ -1073,7 +1073,7 @@
           <a:p>
             <a:fld id="{5BCAD085-E8A6-8845-BD4E-CB4CCA059FC4}" type="datetimeFigureOut">
               <a:rPr lang="en-US" smtClean="0"/>
-              <a:t>2/19/2026</a:t>
+              <a:t>4/8/2026</a:t>
             </a:fld>
             <a:endParaRPr lang="en-US"/>
           </a:p>
@@ -1358,7 +1358,7 @@
           <a:p>
             <a:fld id="{5BCAD085-E8A6-8845-BD4E-CB4CCA059FC4}" type="datetimeFigureOut">
               <a:rPr lang="en-US" smtClean="0"/>
-              <a:t>2/19/2026</a:t>
+              <a:t>4/8/2026</a:t>
             </a:fld>
             <a:endParaRPr lang="en-US"/>
           </a:p>
@@ -1777,7 +1777,7 @@
           <a:p>
             <a:fld id="{5BCAD085-E8A6-8845-BD4E-CB4CCA059FC4}" type="datetimeFigureOut">
               <a:rPr lang="en-US" smtClean="0"/>
-              <a:t>2/19/2026</a:t>
+              <a:t>4/8/2026</a:t>
             </a:fld>
             <a:endParaRPr lang="en-US"/>
           </a:p>
@@ -1894,7 +1894,7 @@
           <a:p>
             <a:fld id="{5BCAD085-E8A6-8845-BD4E-CB4CCA059FC4}" type="datetimeFigureOut">
               <a:rPr lang="en-US" smtClean="0"/>
-              <a:t>2/19/2026</a:t>
+              <a:t>4/8/2026</a:t>
             </a:fld>
             <a:endParaRPr lang="en-US"/>
           </a:p>
@@ -1989,7 +1989,7 @@
           <a:p>
             <a:fld id="{5BCAD085-E8A6-8845-BD4E-CB4CCA059FC4}" type="datetimeFigureOut">
               <a:rPr lang="en-US" smtClean="0"/>
-              <a:t>2/19/2026</a:t>
+              <a:t>4/8/2026</a:t>
             </a:fld>
             <a:endParaRPr lang="en-US"/>
           </a:p>
@@ -2264,7 +2264,7 @@
           <a:p>
             <a:fld id="{5BCAD085-E8A6-8845-BD4E-CB4CCA059FC4}" type="datetimeFigureOut">
               <a:rPr lang="en-US" smtClean="0"/>
-              <a:t>2/19/2026</a:t>
+              <a:t>4/8/2026</a:t>
             </a:fld>
             <a:endParaRPr lang="en-US"/>
           </a:p>
@@ -2516,7 +2516,7 @@
           <a:p>
             <a:fld id="{5BCAD085-E8A6-8845-BD4E-CB4CCA059FC4}" type="datetimeFigureOut">
               <a:rPr lang="en-US" smtClean="0"/>
-              <a:t>2/19/2026</a:t>
+              <a:t>4/8/2026</a:t>
             </a:fld>
             <a:endParaRPr lang="en-US"/>
           </a:p>
@@ -2727,7 +2727,7 @@
           <a:p>
             <a:fld id="{5BCAD085-E8A6-8845-BD4E-CB4CCA059FC4}" type="datetimeFigureOut">
               <a:rPr lang="en-US" smtClean="0"/>
-              <a:t>2/19/2026</a:t>
+              <a:t>4/8/2026</a:t>
             </a:fld>
             <a:endParaRPr lang="en-US"/>
           </a:p>
@@ -6937,16 +6937,34 @@
                   </a:solidFill>
                   <a:latin typeface="Segoe UI"/>
                 </a:rPr>
-                <a:t>There is no mechanism for seat re</a:t>
+                <a:t>There is no mechanism for </a:t>
               </a:r>
               <a:r>
-                <a:rPr lang="en-IN" dirty="0" err="1">
+                <a:rPr>
                   <a:solidFill>
                     <a:srgbClr val="CBD5E1"/>
                   </a:solidFill>
                   <a:latin typeface="Segoe UI"/>
                 </a:rPr>
-                <a:t>servation</a:t>
+                <a:t>seat </a:t>
+              </a:r>
+              <a:r>
+                <a:rPr lang="en-US">
+                  <a:solidFill>
+                    <a:srgbClr val="CBD5E1"/>
+                  </a:solidFill>
+                  <a:latin typeface="Segoe UI"/>
+                </a:rPr>
+                <a:t>reservation</a:t>
+              </a:r>
+              <a:r>
+                <a:rPr>
+                  <a:solidFill>
+                    <a:srgbClr val="CBD5E1"/>
+                  </a:solidFill>
+                  <a:latin typeface="Segoe UI"/>
+                </a:rPr>
+                <a:t>, </a:t>
               </a:r>
               <a:r>
                 <a:rPr dirty="0">
@@ -6955,7 +6973,7 @@
                   </a:solidFill>
                   <a:latin typeface="Segoe UI"/>
                 </a:rPr>
-                <a:t>, resulting in overcrowded buses and poor commuter experience.</a:t>
+                <a:t>resulting in overcrowded buses and poor commuter experience.</a:t>
               </a:r>
             </a:p>
             <a:p>

</xml_diff>